<commit_message>
docs: architectural recommendation, honest wording, rebuilt 8-slide deck
- docs/recommendation.md: specific coupling-graph features from scaling
  data (degree 3, log diameter target, no degree-2 chains, faces<=8)
  with measured numbers and caveats
- Remove 'restores 1.000 everywhere' overclaims from README/docs/deck
- Deck rebuilt from CSVs: 8 slides incl. recommendation, test count
  computed, no hard-coded numbers
</commit_message>
<xml_diff>
--- a/results/reports/quantum-geometry-routing-deck.pptx
+++ b/results/reports/quantum-geometry-routing-deck.pptx
@@ -3359,7 +3359,7 @@
               </a:defRPr>
             </a:pPr>
             <a:r>
-              <a:t>Each SWAP = 3 CNOTs = more noise exposure = worse entanglement.</a:t>
+              <a:t>Each SWAP = more gates = more noise exposure = worse entanglement.</a:t>
             </a:r>
           </a:p>
           <a:p>
@@ -3441,7 +3441,7 @@
               </a:defRPr>
             </a:pPr>
             <a:r>
-              <a:t>Our experiment: 3 x 3 = 9 real simulations</a:t>
+              <a:t>Our experiment: 9 real simulations + a scaling sweep</a:t>
             </a:r>
           </a:p>
         </p:txBody>
@@ -3496,7 +3496,7 @@
               </a:defRPr>
             </a:pPr>
             <a:r>
-              <a:t>Topologies: star (5q, 2016-era), heavy-hex (35q, IBM today), hyperbolic (22q, future idea).</a:t>
+              <a:t>Matrix: T-shape (5q, 2016) x heavy-hex (21q, IBM-style) x hyperbolic {7,3} (20q).</a:t>
             </a:r>
           </a:p>
           <a:p>
@@ -3512,7 +3512,7 @@
               </a:defRPr>
             </a:pPr>
             <a:r>
-              <a:t>Conditions: ideal, noisy (depolarizing + readout), noisy + protection.</a:t>
+              <a:t>Conditions: ideal, noisy (depolarizing + readout), noisy + ancilla protection.</a:t>
             </a:r>
           </a:p>
           <a:p>
@@ -3528,7 +3528,7 @@
               </a:defRPr>
             </a:pPr>
             <a:r>
-              <a:t>Metrics: SWAP count, 2-qubit depth, Bell-state fidelity, post-selection yield.</a:t>
+              <a:t>Scaling sweep: 13 chips, 20 to 127 qubits, 3 families -- how does the worst trip grow?</a:t>
             </a:r>
           </a:p>
         </p:txBody>
@@ -3594,7 +3594,7 @@
               </a:defRPr>
             </a:pPr>
             <a:r>
-              <a:t>How it works</a:t>
+              <a:t>How it works (and why you can trust it)</a:t>
             </a:r>
           </a:p>
         </p:txBody>
@@ -3665,7 +3665,7 @@
               </a:defRPr>
             </a:pPr>
             <a:r>
-              <a:t>Protection = syndrome post-selection: discard shots that fail the parity check.</a:t>
+              <a:t>Protection: an ancilla measures the ZZ then XX stabilizers mid-circuit; we keep only clean-syndrome shots and score the data bits alone.</a:t>
             </a:r>
           </a:p>
           <a:p>
@@ -3681,7 +3681,7 @@
               </a:defRPr>
             </a:pPr>
             <a:r>
-              <a:t>Everything seeded and reproducible: quantum/ -&gt; algorithms/ -&gt; FastAPI -&gt; React dashboard.</a:t>
+              <a:t>Selection and scoring use disjoint bits -- random noise cannot fake F=1.</a:t>
             </a:r>
           </a:p>
         </p:txBody>
@@ -3786,7 +3786,7 @@
               </a:defRPr>
             </a:pPr>
             <a:r>
-              <a:t>Star: 1 SWAP -- tiny chip, neighbors are close.</a:t>
+              <a:t>T-shape (5q, 2016): 2 SWAPs across diameter 3.</a:t>
             </a:r>
           </a:p>
           <a:p>
@@ -3802,7 +3802,7 @@
               </a:defRPr>
             </a:pPr>
             <a:r>
-              <a:t>Heavy-hex: 13 SWAPs -- 35 qubits but a long, sparse map (diameter 14).</a:t>
+              <a:t>heavy-hex (21q, IBM-style): 9 SWAPs across diameter 10.</a:t>
             </a:r>
           </a:p>
           <a:p>
@@ -3818,7 +3818,7 @@
               </a:defRPr>
             </a:pPr>
             <a:r>
-              <a:t>Hyperbolic: 5 SWAPs -- 22 qubits packed at diameter 6 (exponential expansion).</a:t>
+              <a:t>hyperbolic {7,3} (20q, future): 6 SWAPs across diameter 7.</a:t>
             </a:r>
           </a:p>
           <a:p>
@@ -3898,7 +3898,7 @@
               </a:defRPr>
             </a:pPr>
             <a:r>
-              <a:t>SWAPs and circuit depth per topology (worst-case pair)</a:t>
+              <a:t>SWAPs and two-qubit depth per topology (worst-case pair)</a:t>
             </a:r>
           </a:p>
         </p:txBody>
@@ -3964,7 +3964,7 @@
               </a:defRPr>
             </a:pPr>
             <a:r>
-              <a:t>Result 2: noise separates the topologies</a:t>
+              <a:t>Result 2: protection helps -- honestly</a:t>
             </a:r>
           </a:p>
         </p:txBody>
@@ -4003,7 +4003,7 @@
               </a:defRPr>
             </a:pPr>
             <a:r>
-              <a:t>Ideal world: all three hit fidelity 1.000 -- the science is correct.</a:t>
+              <a:t>Noisy fidelity: T-shape 0.920, heavy-hex 0.894, hyperbolic {7,3} 0.907.</a:t>
             </a:r>
           </a:p>
           <a:p>
@@ -4019,7 +4019,7 @@
               </a:defRPr>
             </a:pPr>
             <a:r>
-              <a:t>Noisy world: star 0.919, heavy-hex 0.864, hyperbolic 0.909.</a:t>
+              <a:t>Protected: T-shape 0.934 (+0.014), heavy-hex 0.921 (+0.027), hyperbolic {7,3} 0.928 (+0.020).</a:t>
             </a:r>
           </a:p>
           <a:p>
@@ -4035,7 +4035,7 @@
               </a:defRPr>
             </a:pPr>
             <a:r>
-              <a:t>Protection restores 1.000 everywhere -- but watch what it costs.</a:t>
+              <a:t>Cost of protection: +1 SWAP, +4 CX, ~12% of shots discarded.</a:t>
             </a:r>
           </a:p>
           <a:p>
@@ -4051,7 +4051,7 @@
               </a:defRPr>
             </a:pPr>
             <a:r>
-              <a:t>Longer detours (heavy-hex) collect more errors.</a:t>
+              <a:t>It never reaches 1.0 -- some errors always slip through. That is the honest trade.</a:t>
             </a:r>
           </a:p>
         </p:txBody>
@@ -4181,7 +4181,7 @@
               </a:defRPr>
             </a:pPr>
             <a:r>
-              <a:t>Key finding: protection is a trade, and scaling wins</a:t>
+              <a:t>Result 3: scaling decides the future (recommendation)</a:t>
             </a:r>
           </a:p>
         </p:txBody>
@@ -4220,7 +4220,7 @@
               </a:defRPr>
             </a:pPr>
             <a:r>
-              <a:t>Protection is not free: heavy-hex discards ~9% of shots to recover fidelity; star only ~5%.</a:t>
+              <a:t>At 127 qubits, heavy-hex (real IBM Eagle map) has diameter 26; hyperbolic 152q has diameter 16.</a:t>
             </a:r>
           </a:p>
           <a:p>
@@ -4236,7 +4236,7 @@
               </a:defRPr>
             </a:pPr>
             <a:r>
-              <a:t>Star wins raw fidelity for one Bell pair -- but it cannot scale past 5 qubits.</a:t>
+              <a:t>Heavy-hex scales ~2.3*sqrt(N) -- worse than a plain grid (~1.8*sqrt(N)).</a:t>
             </a:r>
           </a:p>
           <a:p>
@@ -4252,7 +4252,7 @@
               </a:defRPr>
             </a:pPr>
             <a:r>
-              <a:t>Hyperbolic holds 22 qubits at diameter 6; heavy-hex needs diameter 14 for 35.</a:t>
+              <a:t>Recommend: max degree 3, diameter target log(N), no long degree-2 wire chains, small faces (&lt;=8), budget error detection only for the longest routes.</a:t>
             </a:r>
           </a:p>
           <a:p>
@@ -4268,14 +4268,14 @@
               </a:defRPr>
             </a:pPr>
             <a:r>
-              <a:t>Verdict: for cloud-scale entanglement, expansion beats sprawl.</a:t>
+              <a:t>Full evidence: docs/recommendation.md + results/tables/scaling.csv.</a:t>
             </a:r>
           </a:p>
         </p:txBody>
       </p:sp>
       <p:pic>
         <p:nvPicPr>
-          <p:cNvPr id="4" name="Picture 3" descr="protection_tradeoff.png"/>
+          <p:cNvPr id="4" name="Picture 3" descr="scaling_diameter.png"/>
           <p:cNvPicPr>
             <a:picLocks noChangeAspect="1"/>
           </p:cNvPicPr>
@@ -4290,7 +4290,7 @@
         <p:spPr>
           <a:xfrm>
             <a:off x="6309360" y="1463040"/>
-            <a:ext cx="5303520" cy="3788229"/>
+            <a:ext cx="5303520" cy="3241040"/>
           </a:xfrm>
           <a:prstGeom prst="rect">
             <a:avLst/>
@@ -4332,7 +4332,7 @@
               </a:defRPr>
             </a:pPr>
             <a:r>
-              <a:t>Protection restores fidelity (up) at a yield cost (left)</a:t>
+              <a:t>Worst-case hops vs qubit count (log-x): hyperbolic grows slowest</a:t>
             </a:r>
           </a:p>
         </p:txBody>
@@ -4398,7 +4398,7 @@
               </a:defRPr>
             </a:pPr>
             <a:r>
-              <a:t>System and future scope</a:t>
+              <a:t>System and reproducibility</a:t>
             </a:r>
           </a:p>
         </p:txBody>
@@ -4437,7 +4437,7 @@
               </a:defRPr>
             </a:pPr>
             <a:r>
-              <a:t>Modular repo: quantum/ core, algorithms/ matrix, backend/ FastAPI, frontend/ React dashboard.</a:t>
+              <a:t>Modular repo: quantum/ core, algorithms/ matrix+sweep, backend/ FastAPI, frontend/ React.</a:t>
             </a:r>
           </a:p>
           <a:p>
@@ -4453,7 +4453,7 @@
               </a:defRPr>
             </a:pPr>
             <a:r>
-              <a:t>11 pytest tests, seeded reproducibility, docs for every layer.</a:t>
+              <a:t>17 pytest tests, fixed seeds, pinned requirements.</a:t>
             </a:r>
           </a:p>
           <a:p>
@@ -4469,7 +4469,7 @@
               </a:defRPr>
             </a:pPr>
             <a:r>
-              <a:t>Next: real QPU execution, fake-backend noise models, noise-aware routing.</a:t>
+              <a:t>Topologies: T-shape, star, heavy-hex patches (21/35/106), real Eagle-127, {7,3} tiling, grid.</a:t>
             </a:r>
           </a:p>
           <a:p>
@@ -4485,7 +4485,7 @@
               </a:defRPr>
             </a:pPr>
             <a:r>
-              <a:t>The question scales with the hardware -- so does the answer.</a:t>
+              <a:t>Next: real QPU runs, noise-aware routing, non-planar shortcut couplers.</a:t>
             </a:r>
           </a:p>
         </p:txBody>

</xml_diff>